<commit_message>
docs: update municipality clustering presentation
</commit_message>
<xml_diff>
--- a/presentation/экономическая структура муниципалитетов.pptx
+++ b/presentation/экономическая структура муниципалитетов.pptx
@@ -34947,7 +34947,7 @@
               <a:buNone/>
             </a:pPr>
             <a:r>
-              <a:rPr b="0" i="0" lang="en-US" sz="900" u="none" cap="none" strike="noStrike">
+              <a:rPr b="0" i="0" lang="en-US" u="none" cap="none" strike="noStrike">
                 <a:solidFill>
                   <a:srgbClr val="24313A"/>
                 </a:solidFill>
@@ -34958,7 +34958,7 @@
               </a:rPr>
               <a:t>0.8129</a:t>
             </a:r>
-            <a:endParaRPr b="0" i="0" sz="900" u="none" cap="none" strike="noStrike">
+            <a:endParaRPr b="0" i="0" u="none" cap="none" strike="noStrike">
               <a:solidFill>
                 <a:schemeClr val="dk1"/>
               </a:solidFill>

</xml_diff>